<commit_message>
Added an Auto scale for all views in production/customer
</commit_message>
<xml_diff>
--- a/Resources/Templates/CKVD/CKVD_rev2/CKVD_REL_Rev2_07262026.pptx
+++ b/Resources/Templates/CKVD/CKVD_rev2/CKVD_REL_Rev2_07262026.pptx
@@ -233,7 +233,7 @@
           <a:p>
             <a:fld id="{5A2993FE-E9D3-4B10-B499-4235062A8B3B}" type="datetimeFigureOut">
               <a:rPr lang="en-US" smtClean="0"/>
-              <a:t>7/29/2026</a:t>
+              <a:t>10/5/2026</a:t>
             </a:fld>
             <a:endParaRPr lang="en-US"/>
           </a:p>
@@ -411,7 +411,7 @@
           <a:p>
             <a:fld id="{DD2E5E3A-6FB5-47BF-ABCF-397F6C94D529}" type="datetimeFigureOut">
               <a:rPr lang="en-US" smtClean="0"/>
-              <a:t>7/28/2026</a:t>
+              <a:t>10/5/2026</a:t>
             </a:fld>
             <a:endParaRPr lang="en-US" dirty="0"/>
           </a:p>
@@ -14440,8 +14440,22 @@
                 <a:ea typeface="Tahoma" panose="020B0604030504040204" pitchFamily="34" charset="0"/>
                 <a:cs typeface="Tahoma" panose="020B0604030504040204" pitchFamily="34" charset="0"/>
               </a:rPr>
-              <a:t>W parameter will have W_MAX </a:t>
-            </a:r>
+              <a:t>W parameter will have W_MAX -</a:t>
+            </a:r>
+            <a:r>
+              <a:rPr lang="en-US" sz="1400" dirty="0">
+                <a:latin typeface="Tahoma" panose="020B0604030504040204" pitchFamily="34" charset="0"/>
+                <a:ea typeface="Tahoma" panose="020B0604030504040204" pitchFamily="34" charset="0"/>
+                <a:cs typeface="Tahoma" panose="020B0604030504040204" pitchFamily="34" charset="0"/>
+                <a:sym typeface="Wingdings" panose="05000000000000000000" pitchFamily="2" charset="2"/>
+              </a:rPr>
+              <a:t> This might be wrong</a:t>
+            </a:r>
+            <a:endParaRPr lang="en-US" sz="1400" dirty="0">
+              <a:latin typeface="Tahoma" panose="020B0604030504040204" pitchFamily="34" charset="0"/>
+              <a:ea typeface="Tahoma" panose="020B0604030504040204" pitchFamily="34" charset="0"/>
+              <a:cs typeface="Tahoma" panose="020B0604030504040204" pitchFamily="34" charset="0"/>
+            </a:endParaRPr>
           </a:p>
           <a:p>
             <a:r>

</xml_diff>